<commit_message>
Fix navigation, links, and content
- Remove broken About links from all sidebar navs
- Change 'my team' to 'our team' in Writing a Report
- Update intro slides PDF

Co-Authored-By: Claude Sonnet 4.6 <noreply@anthropic.com>
</commit_message>
<xml_diff>
--- a/assets/Distance Ladder Intro Slides.pptx
+++ b/assets/Distance Ladder Intro Slides.pptx
@@ -154,7 +154,7 @@
   <pc:docChgLst>
     <pc:chgData name="Sarah Sweet" userId="667ae3f1-a29f-44ef-a1e5-c5a6e2109699" providerId="ADAL" clId="{31478C3C-9D07-5340-9D5A-FFFCC7F933AB}"/>
     <pc:docChg chg="undo custSel mod addSld delSld modSld">
-      <pc:chgData name="Sarah Sweet" userId="667ae3f1-a29f-44ef-a1e5-c5a6e2109699" providerId="ADAL" clId="{31478C3C-9D07-5340-9D5A-FFFCC7F933AB}" dt="2026-04-14T12:50:20.387" v="523" actId="1076"/>
+      <pc:chgData name="Sarah Sweet" userId="667ae3f1-a29f-44ef-a1e5-c5a6e2109699" providerId="ADAL" clId="{31478C3C-9D07-5340-9D5A-FFFCC7F933AB}" dt="2026-04-14T13:44:06.350" v="529" actId="20577"/>
       <pc:docMkLst>
         <pc:docMk/>
       </pc:docMkLst>
@@ -291,13 +291,13 @@
         </pc:spChg>
       </pc:sldChg>
       <pc:sldChg chg="modSp mod">
-        <pc:chgData name="Sarah Sweet" userId="667ae3f1-a29f-44ef-a1e5-c5a6e2109699" providerId="ADAL" clId="{31478C3C-9D07-5340-9D5A-FFFCC7F933AB}" dt="2026-04-14T12:36:08.317" v="308" actId="20577"/>
+        <pc:chgData name="Sarah Sweet" userId="667ae3f1-a29f-44ef-a1e5-c5a6e2109699" providerId="ADAL" clId="{31478C3C-9D07-5340-9D5A-FFFCC7F933AB}" dt="2026-04-14T13:44:06.350" v="529" actId="20577"/>
         <pc:sldMkLst>
           <pc:docMk/>
           <pc:sldMk cId="2108576849" sldId="263"/>
         </pc:sldMkLst>
         <pc:spChg chg="mod">
-          <ac:chgData name="Sarah Sweet" userId="667ae3f1-a29f-44ef-a1e5-c5a6e2109699" providerId="ADAL" clId="{31478C3C-9D07-5340-9D5A-FFFCC7F933AB}" dt="2026-04-14T12:36:08.317" v="308" actId="20577"/>
+          <ac:chgData name="Sarah Sweet" userId="667ae3f1-a29f-44ef-a1e5-c5a6e2109699" providerId="ADAL" clId="{31478C3C-9D07-5340-9D5A-FFFCC7F933AB}" dt="2026-04-14T13:44:06.350" v="529" actId="20577"/>
           <ac:spMkLst>
             <pc:docMk/>
             <pc:sldMk cId="2108576849" sldId="263"/>
@@ -5170,7 +5170,23 @@
                   <a:srgbClr val="000000"/>
                 </a:solidFill>
               </a:rPr>
-              <a:t>Reports should contain a title, author name, a clearly structured main body and either an abstract or a summary. Aim at writing around 10 pages. Make sure figures are properly labeled etc. Do not include lengthy data tables in your report.</a:t>
+              <a:t>Reports should contain a title, author name, a clearly structured main body and either an abstract or a summary. Aim at writing around </a:t>
+            </a:r>
+            <a:r>
+              <a:rPr lang="en-US" sz="1600">
+                <a:solidFill>
+                  <a:srgbClr val="000000"/>
+                </a:solidFill>
+              </a:rPr>
+              <a:t>10 to 15 pages</a:t>
+            </a:r>
+            <a:r>
+              <a:rPr lang="en-US" sz="1600" dirty="0">
+                <a:solidFill>
+                  <a:srgbClr val="000000"/>
+                </a:solidFill>
+              </a:rPr>
+              <a:t>. Make sure figures are properly labeled etc. Do not include lengthy data tables in your report.</a:t>
             </a:r>
             <a:endParaRPr lang="en-US" sz="1600" b="1" dirty="0">
               <a:solidFill>

</xml_diff>